<commit_message>
interpret: ablation before/after demo, EuInAs 3-phase ACOM, all-samples explainer
- Ablation demo figures (before/after for scattered-norm/radial-only/blur/
  low-q/high-q) added to the explainer PPTX (new slide) and PDF.
- EuInAs_B100 multi-phase ACOM (EuInAs+In+As, calib 0.02184 A^-1/px from .prz
  metadata): zone-axis AMI 0.30 -> orientation is a SECONDARY axis for the
  crystalline EuInAs (vs ~0.05 for molecular IMC); phase AMI 0.08.
- Explainer now covers all samples (IMC SI3/SI4, NaPHI=Na007b_vmax2, EuInAs)
  via cross_all figure + all-samples slide; NaPHI uses the vmax2 run.
- Re-ran battery on Na007b_k60_m097_vmax2 (NaPHI). Collector hardened against
  Windows file locks; superfolder refreshed (7 runs).

Co-Authored-By: Claude Opus 4.8 (1M context) <noreply@anthropic.com>
</commit_message>
<xml_diff>
--- a/docs/explainer/interpretation_explainer.pptx
+++ b/docs/explainer/interpretation_explainer.pptx
@@ -14,6 +14,7 @@
     <p:sldId id="262" r:id="rId13"/>
     <p:sldId id="263" r:id="rId14"/>
     <p:sldId id="264" r:id="rId15"/>
+    <p:sldId id="265" r:id="rId16"/>
   </p:sldIdLst>
   <p:sldSz cx="12191695" cy="6858000" type="screen4x3"/>
   <p:notesSz cx="6858000" cy="9144000"/>
@@ -3348,6 +3349,228 @@
 </p:sld>
 </file>
 
+<file path=ppt/slides/slide10.xml><?xml version="1.0" encoding="utf-8"?>
+<p:sld xmlns:a="http://schemas.openxmlformats.org/drawingml/2006/main" xmlns:p="http://schemas.openxmlformats.org/presentationml/2006/main" xmlns:r="http://schemas.openxmlformats.org/officeDocument/2006/relationships">
+  <p:cSld>
+    <p:spTree>
+      <p:nvGrpSpPr>
+        <p:cNvPr id="1" name=""/>
+        <p:cNvGrpSpPr/>
+        <p:nvPr/>
+      </p:nvGrpSpPr>
+      <p:grpSpPr/>
+      <p:sp>
+        <p:nvSpPr>
+          <p:cNvPr id="2" name="Rectangle 1"/>
+          <p:cNvSpPr/>
+          <p:nvPr/>
+        </p:nvSpPr>
+        <p:spPr>
+          <a:xfrm>
+            <a:off x="0" y="0"/>
+            <a:ext cx="12191695" cy="6858000"/>
+          </a:xfrm>
+          <a:prstGeom prst="rect">
+            <a:avLst/>
+          </a:prstGeom>
+          <a:solidFill>
+            <a:srgbClr val="21295C"/>
+          </a:solidFill>
+          <a:ln>
+            <a:noFill/>
+          </a:ln>
+          <a:effectLst/>
+        </p:spPr>
+        <p:style>
+          <a:lnRef idx="1">
+            <a:schemeClr val="accent1"/>
+          </a:lnRef>
+          <a:fillRef idx="3">
+            <a:schemeClr val="accent1"/>
+          </a:fillRef>
+          <a:effectRef idx="2">
+            <a:schemeClr val="accent1"/>
+          </a:effectRef>
+          <a:fontRef idx="minor">
+            <a:schemeClr val="lt1"/>
+          </a:fontRef>
+        </p:style>
+        <p:txBody>
+          <a:bodyPr rtlCol="0" anchor="ctr"/>
+          <a:lstStyle/>
+          <a:p>
+            <a:pPr algn="ctr"/>
+          </a:p>
+        </p:txBody>
+      </p:sp>
+      <p:sp>
+        <p:nvSpPr>
+          <p:cNvPr id="3" name="Rectangle 2"/>
+          <p:cNvSpPr/>
+          <p:nvPr/>
+        </p:nvSpPr>
+        <p:spPr>
+          <a:xfrm>
+            <a:off x="0" y="0"/>
+            <a:ext cx="292608" cy="6858000"/>
+          </a:xfrm>
+          <a:prstGeom prst="rect">
+            <a:avLst/>
+          </a:prstGeom>
+          <a:solidFill>
+            <a:srgbClr val="E8A33D"/>
+          </a:solidFill>
+          <a:ln>
+            <a:noFill/>
+          </a:ln>
+          <a:effectLst/>
+        </p:spPr>
+        <p:style>
+          <a:lnRef idx="1">
+            <a:schemeClr val="accent1"/>
+          </a:lnRef>
+          <a:fillRef idx="3">
+            <a:schemeClr val="accent1"/>
+          </a:fillRef>
+          <a:effectRef idx="2">
+            <a:schemeClr val="accent1"/>
+          </a:effectRef>
+          <a:fontRef idx="minor">
+            <a:schemeClr val="lt1"/>
+          </a:fontRef>
+        </p:style>
+        <p:txBody>
+          <a:bodyPr rtlCol="0" anchor="ctr"/>
+          <a:lstStyle/>
+          <a:p>
+            <a:pPr algn="ctr"/>
+          </a:p>
+        </p:txBody>
+      </p:sp>
+      <p:sp>
+        <p:nvSpPr>
+          <p:cNvPr id="4" name="TextBox 3"/>
+          <p:cNvSpPr txBox="1"/>
+          <p:nvPr/>
+        </p:nvSpPr>
+        <p:spPr>
+          <a:xfrm>
+            <a:off x="914400" y="548640"/>
+            <a:ext cx="10058400" cy="822960"/>
+          </a:xfrm>
+          <a:prstGeom prst="rect">
+            <a:avLst/>
+          </a:prstGeom>
+          <a:noFill/>
+        </p:spPr>
+        <p:txBody>
+          <a:bodyPr wrap="square" anchor="t" lIns="25400" rIns="25400" tIns="25400" bIns="25400">
+            <a:spAutoFit/>
+          </a:bodyPr>
+          <a:lstStyle/>
+          <a:p>
+            <a:pPr algn="l">
+              <a:lnSpc>
+                <a:spcPct val="105000"/>
+              </a:lnSpc>
+            </a:pPr>
+            <a:r>
+              <a:rPr sz="3400" b="1" i="0">
+                <a:solidFill>
+                  <a:srgbClr val="FFFFFF"/>
+                </a:solidFill>
+                <a:latin typeface="Georgia"/>
+              </a:rPr>
+              <a:t>What it means</a:t>
+            </a:r>
+          </a:p>
+        </p:txBody>
+      </p:sp>
+      <p:sp>
+        <p:nvSpPr>
+          <p:cNvPr id="5" name="TextBox 4"/>
+          <p:cNvSpPr txBox="1"/>
+          <p:nvPr/>
+        </p:nvSpPr>
+        <p:spPr>
+          <a:xfrm>
+            <a:off x="914400" y="1737360"/>
+            <a:ext cx="10424160" cy="4389120"/>
+          </a:xfrm>
+          <a:prstGeom prst="rect">
+            <a:avLst/>
+          </a:prstGeom>
+          <a:noFill/>
+        </p:spPr>
+        <p:txBody>
+          <a:bodyPr wrap="square" anchor="t" lIns="25400" rIns="25400" tIns="25400" bIns="25400">
+            <a:spAutoFit/>
+          </a:bodyPr>
+          <a:lstStyle/>
+          <a:p>
+            <a:pPr algn="l">
+              <a:lnSpc>
+                <a:spcPct val="110000"/>
+              </a:lnSpc>
+            </a:pPr>
+            <a:r>
+              <a:rPr sz="1900" b="0" i="0">
+                <a:solidFill>
+                  <a:srgbClr val="FFFFFF"/>
+                </a:solidFill>
+                <a:latin typeface="Calibri"/>
+              </a:rPr>
+              <a:t>The model groups regions by how much, and what, they diffract at low angles — crystallinity, molecular packing, and thickness. A physically sensible axis, not an arbitrary black box.</a:t>
+            </a:r>
+          </a:p>
+          <a:p>
+            <a:pPr algn="l">
+              <a:lnSpc>
+                <a:spcPct val="110000"/>
+              </a:lnSpc>
+              <a:spcBef>
+                <a:spcPts val="1400"/>
+              </a:spcBef>
+            </a:pPr>
+            <a:r>
+              <a:rPr sz="1600" b="0" i="0">
+                <a:solidFill>
+                  <a:srgbClr val="CADCFC"/>
+                </a:solidFill>
+                <a:latin typeface="Calibri"/>
+              </a:rPr>
+              <a:t>For IMC it is genuinely distinctive (a standard virtual-detector / PCA map does not reproduce it); for NaPHI and EuInAs it stays closer to classical. The crystalline EuInAs additionally tracks crystal orientation (zone-axis), which the molecular films do not.</a:t>
+            </a:r>
+          </a:p>
+          <a:p>
+            <a:pPr algn="l">
+              <a:lnSpc>
+                <a:spcPct val="110000"/>
+              </a:lnSpc>
+              <a:spcBef>
+                <a:spcPts val="1400"/>
+              </a:spcBef>
+            </a:pPr>
+            <a:r>
+              <a:rPr sz="1500" b="0" i="1">
+                <a:solidFill>
+                  <a:srgbClr val="CADCFC"/>
+                </a:solidFill>
+                <a:latin typeface="Calibri"/>
+              </a:rPr>
+              <a:t>Caveat: “scattered intensity” blends crystallinity with sample thickness — a thickness map would separate the two.</a:t>
+            </a:r>
+          </a:p>
+        </p:txBody>
+      </p:sp>
+    </p:spTree>
+  </p:cSld>
+  <p:clrMapOvr>
+    <a:masterClrMapping/>
+  </p:clrMapOvr>
+</p:sld>
+</file>
+
 <file path=ppt/slides/slide2.xml><?xml version="1.0" encoding="utf-8"?>
 <p:sld xmlns:a="http://schemas.openxmlformats.org/drawingml/2006/main" xmlns:p="http://schemas.openxmlformats.org/presentationml/2006/main" xmlns:r="http://schemas.openxmlformats.org/officeDocument/2006/relationships">
   <p:cSld>
@@ -5245,7 +5468,7 @@
         <p:spPr>
           <a:xfrm>
             <a:off x="640080" y="411480"/>
-            <a:ext cx="11338560" cy="731520"/>
+            <a:ext cx="10972800" cy="731520"/>
           </a:xfrm>
           <a:prstGeom prst="rect">
             <a:avLst/>
@@ -5270,277 +5493,14 @@
                 </a:solidFill>
                 <a:latin typeface="Georgia"/>
               </a:rPr>
-              <a:t>Test 3 · Could a classical method do the same?</a:t>
-            </a:r>
-          </a:p>
-        </p:txBody>
-      </p:sp>
-      <p:sp>
-        <p:nvSpPr>
-          <p:cNvPr id="4" name="TextBox 3"/>
-          <p:cNvSpPr txBox="1"/>
-          <p:nvPr/>
-        </p:nvSpPr>
-        <p:spPr>
-          <a:xfrm>
-            <a:off x="640080" y="1325880"/>
-            <a:ext cx="4846320" cy="3291840"/>
-          </a:xfrm>
-          <a:prstGeom prst="rect">
-            <a:avLst/>
-          </a:prstGeom>
-          <a:noFill/>
-        </p:spPr>
-        <p:txBody>
-          <a:bodyPr wrap="square" anchor="t" lIns="25400" rIns="25400" tIns="25400" bIns="25400">
-            <a:spAutoFit/>
-          </a:bodyPr>
-          <a:lstStyle/>
-          <a:p>
-            <a:pPr algn="l">
-              <a:lnSpc>
-                <a:spcPct val="105000"/>
-              </a:lnSpc>
-            </a:pPr>
-            <a:r>
-              <a:rPr sz="1700" b="1" i="0">
-                <a:solidFill>
-                  <a:srgbClr val="1C7293"/>
-                </a:solidFill>
-                <a:latin typeface="Calibri"/>
-              </a:rPr>
-              <a:t>In plain terms</a:t>
-            </a:r>
-          </a:p>
-          <a:p>
-            <a:pPr algn="l">
-              <a:lnSpc>
-                <a:spcPct val="105000"/>
-              </a:lnSpc>
-              <a:spcBef>
-                <a:spcPts val="300"/>
-              </a:spcBef>
-            </a:pPr>
-            <a:r>
-              <a:rPr sz="1500" b="0" i="0">
-                <a:solidFill>
-                  <a:srgbClr val="1A2230"/>
-                </a:solidFill>
-                <a:latin typeface="Calibri"/>
-              </a:rPr>
-              <a:t>Does the AI just redraw what an old-school analysis already shows, or something genuinely new?</a:t>
-            </a:r>
-          </a:p>
-          <a:p>
-            <a:pPr algn="l">
-              <a:lnSpc>
-                <a:spcPct val="105000"/>
-              </a:lnSpc>
-              <a:spcBef>
-                <a:spcPts val="1000"/>
-              </a:spcBef>
-            </a:pPr>
-            <a:r>
-              <a:rPr sz="1700" b="1" i="0">
-                <a:solidFill>
-                  <a:srgbClr val="1C7293"/>
-                </a:solidFill>
-                <a:latin typeface="Calibri"/>
-              </a:rPr>
-              <a:t>How it is measured</a:t>
-            </a:r>
-          </a:p>
-          <a:p>
-            <a:pPr algn="l">
-              <a:lnSpc>
-                <a:spcPct val="105000"/>
-              </a:lnSpc>
-              <a:spcBef>
-                <a:spcPts val="300"/>
-              </a:spcBef>
-            </a:pPr>
-            <a:r>
-              <a:rPr sz="1500" b="0" i="0">
-                <a:solidFill>
-                  <a:srgbClr val="1A2230"/>
-                </a:solidFill>
-                <a:latin typeface="Calibri"/>
-              </a:rPr>
-              <a:t>Cluster classical features — virtual dark-field, azimuthal profile, PCA / NMF of the pattern — into the same number of groups, and measure agreement with the AI map (ARI / AMI).</a:t>
-            </a:r>
-          </a:p>
-        </p:txBody>
-      </p:sp>
-      <p:sp>
-        <p:nvSpPr>
-          <p:cNvPr id="5" name="Rounded Rectangle 4"/>
-          <p:cNvSpPr/>
-          <p:nvPr/>
-        </p:nvSpPr>
-        <p:spPr>
-          <a:xfrm>
-            <a:off x="640080" y="4709160"/>
-            <a:ext cx="4846320" cy="1600200"/>
-          </a:xfrm>
-          <a:prstGeom prst="roundRect">
-            <a:avLst/>
-          </a:prstGeom>
-          <a:solidFill>
-            <a:srgbClr val="21295C"/>
-          </a:solidFill>
-          <a:ln>
-            <a:noFill/>
-          </a:ln>
-          <a:effectLst/>
-        </p:spPr>
-        <p:style>
-          <a:lnRef idx="1">
-            <a:schemeClr val="accent1"/>
-          </a:lnRef>
-          <a:fillRef idx="3">
-            <a:schemeClr val="accent1"/>
-          </a:fillRef>
-          <a:effectRef idx="2">
-            <a:schemeClr val="accent1"/>
-          </a:effectRef>
-          <a:fontRef idx="minor">
-            <a:schemeClr val="lt1"/>
-          </a:fontRef>
-        </p:style>
-        <p:txBody>
-          <a:bodyPr rtlCol="0" anchor="ctr"/>
-          <a:lstStyle/>
-          <a:p>
-            <a:pPr algn="ctr"/>
-          </a:p>
-        </p:txBody>
-      </p:sp>
-      <p:sp>
-        <p:nvSpPr>
-          <p:cNvPr id="6" name="TextBox 5"/>
-          <p:cNvSpPr txBox="1"/>
-          <p:nvPr/>
-        </p:nvSpPr>
-        <p:spPr>
-          <a:xfrm>
-            <a:off x="868680" y="4846320"/>
-            <a:ext cx="4434840" cy="1371600"/>
-          </a:xfrm>
-          <a:prstGeom prst="rect">
-            <a:avLst/>
-          </a:prstGeom>
-          <a:noFill/>
-        </p:spPr>
-        <p:txBody>
-          <a:bodyPr wrap="square" anchor="ctr" lIns="25400" rIns="25400" tIns="25400" bIns="25400">
-            <a:spAutoFit/>
-          </a:bodyPr>
-          <a:lstStyle/>
-          <a:p>
-            <a:pPr algn="l">
-              <a:lnSpc>
-                <a:spcPct val="105000"/>
-              </a:lnSpc>
-            </a:pPr>
-            <a:r>
-              <a:rPr sz="1500" b="1" i="0">
-                <a:solidFill>
-                  <a:srgbClr val="E8A33D"/>
-                </a:solidFill>
-                <a:latin typeface="Calibri"/>
-              </a:rPr>
-              <a:t>Uniqueness is material-dependent</a:t>
-            </a:r>
-          </a:p>
-          <a:p>
-            <a:pPr algn="l">
-              <a:lnSpc>
-                <a:spcPct val="105000"/>
-              </a:lnSpc>
-              <a:spcBef>
-                <a:spcPts val="600"/>
-              </a:spcBef>
-            </a:pPr>
-            <a:r>
-              <a:rPr sz="1400" b="0" i="0">
-                <a:solidFill>
-                  <a:srgbClr val="FFFFFF"/>
-                </a:solidFill>
-                <a:latin typeface="Calibri"/>
-              </a:rPr>
-              <a:t>IMC: classical agreement ARI ≈ 0.15 → the AI map is distinctive (classical methods miss the fine grains).</a:t>
-            </a:r>
-          </a:p>
-          <a:p>
-            <a:pPr algn="l">
-              <a:lnSpc>
-                <a:spcPct val="105000"/>
-              </a:lnSpc>
-              <a:spcBef>
-                <a:spcPts val="600"/>
-              </a:spcBef>
-            </a:pPr>
-            <a:r>
-              <a:rPr sz="1400" b="0" i="0">
-                <a:solidFill>
-                  <a:srgbClr val="CADCFC"/>
-                </a:solidFill>
-                <a:latin typeface="Calibri"/>
-              </a:rPr>
-              <a:t>NaPHI: ARI ≈ 0.5 → about half-classical.</a:t>
-            </a:r>
-          </a:p>
-        </p:txBody>
-      </p:sp>
-      <p:sp>
-        <p:nvSpPr>
-          <p:cNvPr id="7" name="Rounded Rectangle 6"/>
-          <p:cNvSpPr/>
-          <p:nvPr/>
-        </p:nvSpPr>
-        <p:spPr>
-          <a:xfrm>
-            <a:off x="5760720" y="1874519"/>
-            <a:ext cx="5852160" cy="3108960"/>
-          </a:xfrm>
-          <a:prstGeom prst="roundRect">
-            <a:avLst/>
-          </a:prstGeom>
-          <a:solidFill>
-            <a:srgbClr val="FFFFFF"/>
-          </a:solidFill>
-          <a:ln w="12700">
-            <a:solidFill>
-              <a:srgbClr val="CADCFC"/>
-            </a:solidFill>
-          </a:ln>
-          <a:effectLst/>
-        </p:spPr>
-        <p:style>
-          <a:lnRef idx="1">
-            <a:schemeClr val="accent1"/>
-          </a:lnRef>
-          <a:fillRef idx="3">
-            <a:schemeClr val="accent1"/>
-          </a:fillRef>
-          <a:effectRef idx="2">
-            <a:schemeClr val="accent1"/>
-          </a:effectRef>
-          <a:fontRef idx="minor">
-            <a:schemeClr val="lt1"/>
-          </a:fontRef>
-        </p:style>
-        <p:txBody>
-          <a:bodyPr rtlCol="0" anchor="ctr"/>
-          <a:lstStyle/>
-          <a:p>
-            <a:pPr algn="ctr"/>
+              <a:t>What each edit does — before vs. after</a:t>
+            </a:r>
           </a:p>
         </p:txBody>
       </p:sp>
       <p:pic>
         <p:nvPicPr>
-          <p:cNvPr id="8" name="Picture 7" descr="imc_dino_vs_classical.png"/>
+          <p:cNvPr id="4" name="Picture 3" descr="ablation_demo.png"/>
           <p:cNvPicPr>
             <a:picLocks noChangeAspect="1"/>
           </p:cNvPicPr>
@@ -5554,8 +5514,8 @@
         </p:blipFill>
         <p:spPr>
           <a:xfrm>
-            <a:off x="5943600" y="2712869"/>
-            <a:ext cx="5486400" cy="1112220"/>
+            <a:off x="885067" y="1097280"/>
+            <a:ext cx="2801864" cy="5577840"/>
           </a:xfrm>
           <a:prstGeom prst="rect">
             <a:avLst/>
@@ -5564,14 +5524,14 @@
       </p:pic>
       <p:sp>
         <p:nvSpPr>
-          <p:cNvPr id="9" name="TextBox 8"/>
+          <p:cNvPr id="5" name="TextBox 4"/>
           <p:cNvSpPr txBox="1"/>
           <p:nvPr/>
         </p:nvSpPr>
         <p:spPr>
           <a:xfrm>
-            <a:off x="5943600" y="4498848"/>
-            <a:ext cx="5486400" cy="301752"/>
+            <a:off x="4297680" y="1371600"/>
+            <a:ext cx="7315200" cy="5120640"/>
           </a:xfrm>
           <a:prstGeom prst="rect">
             <a:avLst/>
@@ -5584,19 +5544,114 @@
           </a:bodyPr>
           <a:lstStyle/>
           <a:p>
-            <a:pPr algn="ctr">
+            <a:pPr algn="l">
               <a:lnSpc>
                 <a:spcPct val="105000"/>
               </a:lnSpc>
             </a:pPr>
             <a:r>
-              <a:rPr sz="1100" b="0" i="1">
-                <a:solidFill>
-                  <a:srgbClr val="5A6678"/>
+              <a:rPr sz="1700" b="1" i="0">
+                <a:solidFill>
+                  <a:srgbClr val="1C7293"/>
                 </a:solidFill>
                 <a:latin typeface="Calibri"/>
               </a:rPr>
-              <a:t>IMC: DINO (far left) vs. classical clusterings. Colours are arbitrary; shape match is what counts.</a:t>
+              <a:t>Same diffraction pattern, edited one way at a time:</a:t>
+            </a:r>
+          </a:p>
+          <a:p>
+            <a:pPr algn="l">
+              <a:lnSpc>
+                <a:spcPct val="105000"/>
+              </a:lnSpc>
+              <a:spcBef>
+                <a:spcPts val="1000"/>
+              </a:spcBef>
+            </a:pPr>
+            <a:r>
+              <a:rPr sz="1500" b="0" i="0">
+                <a:solidFill>
+                  <a:srgbClr val="1A2230"/>
+                </a:solidFill>
+                <a:latin typeface="Calibri"/>
+              </a:rPr>
+              <a:t>• scattered-norm — rescales the overall brightness away (keeps the pattern, removes ‘how much it scatters’).</a:t>
+            </a:r>
+          </a:p>
+          <a:p>
+            <a:pPr algn="l">
+              <a:lnSpc>
+                <a:spcPct val="105000"/>
+              </a:lnSpc>
+              <a:spcBef>
+                <a:spcPts val="800"/>
+              </a:spcBef>
+            </a:pPr>
+            <a:r>
+              <a:rPr sz="1500" b="0" i="0">
+                <a:solidFill>
+                  <a:srgbClr val="1A2230"/>
+                </a:solidFill>
+                <a:latin typeface="Calibri"/>
+              </a:rPr>
+              <a:t>• radial-only — keeps the rings, erases all angular detail.</a:t>
+            </a:r>
+          </a:p>
+          <a:p>
+            <a:pPr algn="l">
+              <a:lnSpc>
+                <a:spcPct val="105000"/>
+              </a:lnSpc>
+              <a:spcBef>
+                <a:spcPts val="800"/>
+              </a:spcBef>
+            </a:pPr>
+            <a:r>
+              <a:rPr sz="1500" b="0" i="0">
+                <a:solidFill>
+                  <a:srgbClr val="1A2230"/>
+                </a:solidFill>
+                <a:latin typeface="Calibri"/>
+              </a:rPr>
+              <a:t>• blur — washes out the sharp Bragg spots.</a:t>
+            </a:r>
+          </a:p>
+          <a:p>
+            <a:pPr algn="l">
+              <a:lnSpc>
+                <a:spcPct val="105000"/>
+              </a:lnSpc>
+              <a:spcBef>
+                <a:spcPts val="800"/>
+              </a:spcBef>
+            </a:pPr>
+            <a:r>
+              <a:rPr sz="1500" b="0" i="0">
+                <a:solidFill>
+                  <a:srgbClr val="1A2230"/>
+                </a:solidFill>
+                <a:latin typeface="Calibri"/>
+              </a:rPr>
+              <a:t>• mask low-q / high-q — blanks the inner / outer rings.</a:t>
+            </a:r>
+          </a:p>
+          <a:p>
+            <a:pPr algn="l">
+              <a:lnSpc>
+                <a:spcPct val="105000"/>
+              </a:lnSpc>
+              <a:spcBef>
+                <a:spcPts val="1400"/>
+              </a:spcBef>
+            </a:pPr>
+            <a:r>
+              <a:rPr sz="1500" b="0" i="1">
+                <a:solidFill>
+                  <a:srgbClr val="065A82"/>
+                </a:solidFill>
+                <a:latin typeface="Calibri"/>
+              </a:rPr>
+              <a:t>We re-run the model on each edited version and check whether the map survives (Test 2). The edits that break the map reveal what the model relies on.</a:t>
             </a:r>
           </a:p>
         </p:txBody>
@@ -5672,7 +5727,7 @@
         <p:spPr>
           <a:xfrm>
             <a:off x="640080" y="411480"/>
-            <a:ext cx="10972800" cy="731520"/>
+            <a:ext cx="11338560" cy="731520"/>
           </a:xfrm>
           <a:prstGeom prst="rect">
             <a:avLst/>
@@ -5691,27 +5746,244 @@
               </a:lnSpc>
             </a:pPr>
             <a:r>
-              <a:rPr sz="3200" b="1" i="0">
+              <a:rPr sz="3000" b="1" i="0">
                 <a:solidFill>
                   <a:srgbClr val="065A82"/>
                 </a:solidFill>
                 <a:latin typeface="Georgia"/>
               </a:rPr>
-              <a:t>How to read the two numbers</a:t>
-            </a:r>
-          </a:p>
-        </p:txBody>
-      </p:sp>
-      <p:sp>
-        <p:nvSpPr>
-          <p:cNvPr id="4" name="Rounded Rectangle 3"/>
+              <a:t>Test 3 · Could a classical method do the same?</a:t>
+            </a:r>
+          </a:p>
+        </p:txBody>
+      </p:sp>
+      <p:sp>
+        <p:nvSpPr>
+          <p:cNvPr id="4" name="TextBox 3"/>
+          <p:cNvSpPr txBox="1"/>
+          <p:nvPr/>
+        </p:nvSpPr>
+        <p:spPr>
+          <a:xfrm>
+            <a:off x="640080" y="1325880"/>
+            <a:ext cx="4846320" cy="3291840"/>
+          </a:xfrm>
+          <a:prstGeom prst="rect">
+            <a:avLst/>
+          </a:prstGeom>
+          <a:noFill/>
+        </p:spPr>
+        <p:txBody>
+          <a:bodyPr wrap="square" anchor="t" lIns="25400" rIns="25400" tIns="25400" bIns="25400">
+            <a:spAutoFit/>
+          </a:bodyPr>
+          <a:lstStyle/>
+          <a:p>
+            <a:pPr algn="l">
+              <a:lnSpc>
+                <a:spcPct val="105000"/>
+              </a:lnSpc>
+            </a:pPr>
+            <a:r>
+              <a:rPr sz="1700" b="1" i="0">
+                <a:solidFill>
+                  <a:srgbClr val="1C7293"/>
+                </a:solidFill>
+                <a:latin typeface="Calibri"/>
+              </a:rPr>
+              <a:t>In plain terms</a:t>
+            </a:r>
+          </a:p>
+          <a:p>
+            <a:pPr algn="l">
+              <a:lnSpc>
+                <a:spcPct val="105000"/>
+              </a:lnSpc>
+              <a:spcBef>
+                <a:spcPts val="300"/>
+              </a:spcBef>
+            </a:pPr>
+            <a:r>
+              <a:rPr sz="1500" b="0" i="0">
+                <a:solidFill>
+                  <a:srgbClr val="1A2230"/>
+                </a:solidFill>
+                <a:latin typeface="Calibri"/>
+              </a:rPr>
+              <a:t>Does the AI just redraw what an old-school analysis already shows, or something genuinely new?</a:t>
+            </a:r>
+          </a:p>
+          <a:p>
+            <a:pPr algn="l">
+              <a:lnSpc>
+                <a:spcPct val="105000"/>
+              </a:lnSpc>
+              <a:spcBef>
+                <a:spcPts val="1000"/>
+              </a:spcBef>
+            </a:pPr>
+            <a:r>
+              <a:rPr sz="1700" b="1" i="0">
+                <a:solidFill>
+                  <a:srgbClr val="1C7293"/>
+                </a:solidFill>
+                <a:latin typeface="Calibri"/>
+              </a:rPr>
+              <a:t>How it is measured</a:t>
+            </a:r>
+          </a:p>
+          <a:p>
+            <a:pPr algn="l">
+              <a:lnSpc>
+                <a:spcPct val="105000"/>
+              </a:lnSpc>
+              <a:spcBef>
+                <a:spcPts val="300"/>
+              </a:spcBef>
+            </a:pPr>
+            <a:r>
+              <a:rPr sz="1500" b="0" i="0">
+                <a:solidFill>
+                  <a:srgbClr val="1A2230"/>
+                </a:solidFill>
+                <a:latin typeface="Calibri"/>
+              </a:rPr>
+              <a:t>Cluster classical features — virtual dark-field, azimuthal profile, PCA / NMF of the pattern — into the same number of groups, and measure agreement with the AI map (ARI / AMI).</a:t>
+            </a:r>
+          </a:p>
+        </p:txBody>
+      </p:sp>
+      <p:sp>
+        <p:nvSpPr>
+          <p:cNvPr id="5" name="Rounded Rectangle 4"/>
           <p:cNvSpPr/>
           <p:nvPr/>
         </p:nvSpPr>
         <p:spPr>
           <a:xfrm>
-            <a:off x="822960" y="1737360"/>
-            <a:ext cx="10515600" cy="1920240"/>
+            <a:off x="640080" y="4709160"/>
+            <a:ext cx="4846320" cy="1600200"/>
+          </a:xfrm>
+          <a:prstGeom prst="roundRect">
+            <a:avLst/>
+          </a:prstGeom>
+          <a:solidFill>
+            <a:srgbClr val="21295C"/>
+          </a:solidFill>
+          <a:ln>
+            <a:noFill/>
+          </a:ln>
+          <a:effectLst/>
+        </p:spPr>
+        <p:style>
+          <a:lnRef idx="1">
+            <a:schemeClr val="accent1"/>
+          </a:lnRef>
+          <a:fillRef idx="3">
+            <a:schemeClr val="accent1"/>
+          </a:fillRef>
+          <a:effectRef idx="2">
+            <a:schemeClr val="accent1"/>
+          </a:effectRef>
+          <a:fontRef idx="minor">
+            <a:schemeClr val="lt1"/>
+          </a:fontRef>
+        </p:style>
+        <p:txBody>
+          <a:bodyPr rtlCol="0" anchor="ctr"/>
+          <a:lstStyle/>
+          <a:p>
+            <a:pPr algn="ctr"/>
+          </a:p>
+        </p:txBody>
+      </p:sp>
+      <p:sp>
+        <p:nvSpPr>
+          <p:cNvPr id="6" name="TextBox 5"/>
+          <p:cNvSpPr txBox="1"/>
+          <p:nvPr/>
+        </p:nvSpPr>
+        <p:spPr>
+          <a:xfrm>
+            <a:off x="868680" y="4846320"/>
+            <a:ext cx="4434840" cy="1371600"/>
+          </a:xfrm>
+          <a:prstGeom prst="rect">
+            <a:avLst/>
+          </a:prstGeom>
+          <a:noFill/>
+        </p:spPr>
+        <p:txBody>
+          <a:bodyPr wrap="square" anchor="ctr" lIns="25400" rIns="25400" tIns="25400" bIns="25400">
+            <a:spAutoFit/>
+          </a:bodyPr>
+          <a:lstStyle/>
+          <a:p>
+            <a:pPr algn="l">
+              <a:lnSpc>
+                <a:spcPct val="105000"/>
+              </a:lnSpc>
+            </a:pPr>
+            <a:r>
+              <a:rPr sz="1500" b="1" i="0">
+                <a:solidFill>
+                  <a:srgbClr val="E8A33D"/>
+                </a:solidFill>
+                <a:latin typeface="Calibri"/>
+              </a:rPr>
+              <a:t>Uniqueness is material-dependent</a:t>
+            </a:r>
+          </a:p>
+          <a:p>
+            <a:pPr algn="l">
+              <a:lnSpc>
+                <a:spcPct val="105000"/>
+              </a:lnSpc>
+              <a:spcBef>
+                <a:spcPts val="600"/>
+              </a:spcBef>
+            </a:pPr>
+            <a:r>
+              <a:rPr sz="1400" b="0" i="0">
+                <a:solidFill>
+                  <a:srgbClr val="FFFFFF"/>
+                </a:solidFill>
+                <a:latin typeface="Calibri"/>
+              </a:rPr>
+              <a:t>IMC: classical agreement ARI ≈ 0.15 → the AI map is distinctive (classical methods miss the fine grains).</a:t>
+            </a:r>
+          </a:p>
+          <a:p>
+            <a:pPr algn="l">
+              <a:lnSpc>
+                <a:spcPct val="105000"/>
+              </a:lnSpc>
+              <a:spcBef>
+                <a:spcPts val="600"/>
+              </a:spcBef>
+            </a:pPr>
+            <a:r>
+              <a:rPr sz="1400" b="0" i="0">
+                <a:solidFill>
+                  <a:srgbClr val="CADCFC"/>
+                </a:solidFill>
+                <a:latin typeface="Calibri"/>
+              </a:rPr>
+              <a:t>NaPHI: ARI ≈ 0.5 → about half-classical.</a:t>
+            </a:r>
+          </a:p>
+        </p:txBody>
+      </p:sp>
+      <p:sp>
+        <p:nvSpPr>
+          <p:cNvPr id="7" name="Rounded Rectangle 6"/>
+          <p:cNvSpPr/>
+          <p:nvPr/>
+        </p:nvSpPr>
+        <p:spPr>
+          <a:xfrm>
+            <a:off x="5760720" y="1874519"/>
+            <a:ext cx="5852160" cy="3108960"/>
           </a:xfrm>
           <a:prstGeom prst="roundRect">
             <a:avLst/>
@@ -5748,60 +6020,40 @@
           </a:p>
         </p:txBody>
       </p:sp>
-      <p:sp>
-        <p:nvSpPr>
-          <p:cNvPr id="5" name="Rectangle 4"/>
-          <p:cNvSpPr/>
-          <p:nvPr/>
-        </p:nvSpPr>
-        <p:spPr>
-          <a:xfrm>
-            <a:off x="822960" y="1737360"/>
-            <a:ext cx="201168" cy="1920240"/>
+      <p:pic>
+        <p:nvPicPr>
+          <p:cNvPr id="8" name="Picture 7" descr="imc_dino_vs_classical.png"/>
+          <p:cNvPicPr>
+            <a:picLocks noChangeAspect="1"/>
+          </p:cNvPicPr>
+          <p:nvPr/>
+        </p:nvPicPr>
+        <p:blipFill>
+          <a:blip r:embed="rId2"/>
+          <a:stretch>
+            <a:fillRect/>
+          </a:stretch>
+        </p:blipFill>
+        <p:spPr>
+          <a:xfrm>
+            <a:off x="5943600" y="2712869"/>
+            <a:ext cx="5486400" cy="1112220"/>
           </a:xfrm>
           <a:prstGeom prst="rect">
             <a:avLst/>
           </a:prstGeom>
-          <a:solidFill>
-            <a:srgbClr val="065A82"/>
-          </a:solidFill>
-          <a:ln>
-            <a:noFill/>
-          </a:ln>
-          <a:effectLst/>
-        </p:spPr>
-        <p:style>
-          <a:lnRef idx="1">
-            <a:schemeClr val="accent1"/>
-          </a:lnRef>
-          <a:fillRef idx="3">
-            <a:schemeClr val="accent1"/>
-          </a:fillRef>
-          <a:effectRef idx="2">
-            <a:schemeClr val="accent1"/>
-          </a:effectRef>
-          <a:fontRef idx="minor">
-            <a:schemeClr val="lt1"/>
-          </a:fontRef>
-        </p:style>
-        <p:txBody>
-          <a:bodyPr rtlCol="0" anchor="ctr"/>
-          <a:lstStyle/>
-          <a:p>
-            <a:pPr algn="ctr"/>
-          </a:p>
-        </p:txBody>
-      </p:sp>
-      <p:sp>
-        <p:nvSpPr>
-          <p:cNvPr id="6" name="TextBox 5"/>
+        </p:spPr>
+      </p:pic>
+      <p:sp>
+        <p:nvSpPr>
+          <p:cNvPr id="9" name="TextBox 8"/>
           <p:cNvSpPr txBox="1"/>
           <p:nvPr/>
         </p:nvSpPr>
         <p:spPr>
           <a:xfrm>
-            <a:off x="1188720" y="1737360"/>
-            <a:ext cx="3108960" cy="1920240"/>
+            <a:off x="5943600" y="4498848"/>
+            <a:ext cx="5486400" cy="301752"/>
           </a:xfrm>
           <a:prstGeom prst="rect">
             <a:avLst/>
@@ -5809,269 +6061,24 @@
           <a:noFill/>
         </p:spPr>
         <p:txBody>
-          <a:bodyPr wrap="square" anchor="ctr" lIns="25400" rIns="25400" tIns="25400" bIns="25400">
+          <a:bodyPr wrap="square" anchor="t" lIns="25400" rIns="25400" tIns="25400" bIns="25400">
             <a:spAutoFit/>
           </a:bodyPr>
           <a:lstStyle/>
           <a:p>
-            <a:pPr algn="l">
+            <a:pPr algn="ctr">
               <a:lnSpc>
                 <a:spcPct val="105000"/>
               </a:lnSpc>
             </a:pPr>
             <a:r>
-              <a:rPr sz="3400" b="1" i="0">
-                <a:solidFill>
-                  <a:srgbClr val="065A82"/>
-                </a:solidFill>
-                <a:latin typeface="Georgia"/>
-              </a:rPr>
-              <a:t>R²</a:t>
-            </a:r>
-          </a:p>
-        </p:txBody>
-      </p:sp>
-      <p:sp>
-        <p:nvSpPr>
-          <p:cNvPr id="7" name="TextBox 6"/>
-          <p:cNvSpPr txBox="1"/>
-          <p:nvPr/>
-        </p:nvSpPr>
-        <p:spPr>
-          <a:xfrm>
-            <a:off x="4480560" y="1737360"/>
-            <a:ext cx="6675120" cy="1920240"/>
-          </a:xfrm>
-          <a:prstGeom prst="rect">
-            <a:avLst/>
-          </a:prstGeom>
-          <a:noFill/>
-        </p:spPr>
-        <p:txBody>
-          <a:bodyPr wrap="square" anchor="ctr" lIns="25400" rIns="25400" tIns="25400" bIns="25400">
-            <a:spAutoFit/>
-          </a:bodyPr>
-          <a:lstStyle/>
-          <a:p>
-            <a:pPr algn="l">
-              <a:lnSpc>
-                <a:spcPct val="105000"/>
-              </a:lnSpc>
-            </a:pPr>
-            <a:r>
-              <a:rPr sz="1600" b="1" i="0">
-                <a:solidFill>
-                  <a:srgbClr val="1A2230"/>
+              <a:rPr sz="1100" b="0" i="1">
+                <a:solidFill>
+                  <a:srgbClr val="5A6678"/>
                 </a:solidFill>
                 <a:latin typeface="Calibri"/>
               </a:rPr>
-              <a:t>How predictable a property is from the model's fingerprint.</a:t>
-            </a:r>
-          </a:p>
-          <a:p>
-            <a:pPr algn="l">
-              <a:lnSpc>
-                <a:spcPct val="105000"/>
-              </a:lnSpc>
-              <a:spcBef>
-                <a:spcPts val="800"/>
-              </a:spcBef>
-            </a:pPr>
-            <a:r>
-              <a:rPr sz="1600" b="0" i="0">
-                <a:solidFill>
-                  <a:srgbClr val="5A6678"/>
-                </a:solidFill>
-                <a:latin typeface="Calibri"/>
-              </a:rPr>
-              <a:t>0 = the model ignores it     →     1 = fully encoded</a:t>
-            </a:r>
-          </a:p>
-        </p:txBody>
-      </p:sp>
-      <p:sp>
-        <p:nvSpPr>
-          <p:cNvPr id="8" name="Rounded Rectangle 7"/>
-          <p:cNvSpPr/>
-          <p:nvPr/>
-        </p:nvSpPr>
-        <p:spPr>
-          <a:xfrm>
-            <a:off x="822960" y="3977639"/>
-            <a:ext cx="10515600" cy="1920240"/>
-          </a:xfrm>
-          <a:prstGeom prst="roundRect">
-            <a:avLst/>
-          </a:prstGeom>
-          <a:solidFill>
-            <a:srgbClr val="FFFFFF"/>
-          </a:solidFill>
-          <a:ln w="12700">
-            <a:solidFill>
-              <a:srgbClr val="CADCFC"/>
-            </a:solidFill>
-          </a:ln>
-          <a:effectLst/>
-        </p:spPr>
-        <p:style>
-          <a:lnRef idx="1">
-            <a:schemeClr val="accent1"/>
-          </a:lnRef>
-          <a:fillRef idx="3">
-            <a:schemeClr val="accent1"/>
-          </a:fillRef>
-          <a:effectRef idx="2">
-            <a:schemeClr val="accent1"/>
-          </a:effectRef>
-          <a:fontRef idx="minor">
-            <a:schemeClr val="lt1"/>
-          </a:fontRef>
-        </p:style>
-        <p:txBody>
-          <a:bodyPr rtlCol="0" anchor="ctr"/>
-          <a:lstStyle/>
-          <a:p>
-            <a:pPr algn="ctr"/>
-          </a:p>
-        </p:txBody>
-      </p:sp>
-      <p:sp>
-        <p:nvSpPr>
-          <p:cNvPr id="9" name="Rectangle 8"/>
-          <p:cNvSpPr/>
-          <p:nvPr/>
-        </p:nvSpPr>
-        <p:spPr>
-          <a:xfrm>
-            <a:off x="822960" y="3977639"/>
-            <a:ext cx="201168" cy="1920240"/>
-          </a:xfrm>
-          <a:prstGeom prst="rect">
-            <a:avLst/>
-          </a:prstGeom>
-          <a:solidFill>
-            <a:srgbClr val="1C7293"/>
-          </a:solidFill>
-          <a:ln>
-            <a:noFill/>
-          </a:ln>
-          <a:effectLst/>
-        </p:spPr>
-        <p:style>
-          <a:lnRef idx="1">
-            <a:schemeClr val="accent1"/>
-          </a:lnRef>
-          <a:fillRef idx="3">
-            <a:schemeClr val="accent1"/>
-          </a:fillRef>
-          <a:effectRef idx="2">
-            <a:schemeClr val="accent1"/>
-          </a:effectRef>
-          <a:fontRef idx="minor">
-            <a:schemeClr val="lt1"/>
-          </a:fontRef>
-        </p:style>
-        <p:txBody>
-          <a:bodyPr rtlCol="0" anchor="ctr"/>
-          <a:lstStyle/>
-          <a:p>
-            <a:pPr algn="ctr"/>
-          </a:p>
-        </p:txBody>
-      </p:sp>
-      <p:sp>
-        <p:nvSpPr>
-          <p:cNvPr id="10" name="TextBox 9"/>
-          <p:cNvSpPr txBox="1"/>
-          <p:nvPr/>
-        </p:nvSpPr>
-        <p:spPr>
-          <a:xfrm>
-            <a:off x="1188720" y="3977639"/>
-            <a:ext cx="3108960" cy="1920240"/>
-          </a:xfrm>
-          <a:prstGeom prst="rect">
-            <a:avLst/>
-          </a:prstGeom>
-          <a:noFill/>
-        </p:spPr>
-        <p:txBody>
-          <a:bodyPr wrap="square" anchor="ctr" lIns="25400" rIns="25400" tIns="25400" bIns="25400">
-            <a:spAutoFit/>
-          </a:bodyPr>
-          <a:lstStyle/>
-          <a:p>
-            <a:pPr algn="l">
-              <a:lnSpc>
-                <a:spcPct val="105000"/>
-              </a:lnSpc>
-            </a:pPr>
-            <a:r>
-              <a:rPr sz="3400" b="1" i="0">
-                <a:solidFill>
-                  <a:srgbClr val="1C7293"/>
-                </a:solidFill>
-                <a:latin typeface="Georgia"/>
-              </a:rPr>
-              <a:t>ARI / AMI</a:t>
-            </a:r>
-          </a:p>
-        </p:txBody>
-      </p:sp>
-      <p:sp>
-        <p:nvSpPr>
-          <p:cNvPr id="11" name="TextBox 10"/>
-          <p:cNvSpPr txBox="1"/>
-          <p:nvPr/>
-        </p:nvSpPr>
-        <p:spPr>
-          <a:xfrm>
-            <a:off x="4480560" y="3977639"/>
-            <a:ext cx="6675120" cy="1920240"/>
-          </a:xfrm>
-          <a:prstGeom prst="rect">
-            <a:avLst/>
-          </a:prstGeom>
-          <a:noFill/>
-        </p:spPr>
-        <p:txBody>
-          <a:bodyPr wrap="square" anchor="ctr" lIns="25400" rIns="25400" tIns="25400" bIns="25400">
-            <a:spAutoFit/>
-          </a:bodyPr>
-          <a:lstStyle/>
-          <a:p>
-            <a:pPr algn="l">
-              <a:lnSpc>
-                <a:spcPct val="105000"/>
-              </a:lnSpc>
-            </a:pPr>
-            <a:r>
-              <a:rPr sz="1600" b="1" i="0">
-                <a:solidFill>
-                  <a:srgbClr val="1A2230"/>
-                </a:solidFill>
-                <a:latin typeface="Calibri"/>
-              </a:rPr>
-              <a:t>How much two maps agree, correcting for chance.</a:t>
-            </a:r>
-          </a:p>
-          <a:p>
-            <a:pPr algn="l">
-              <a:lnSpc>
-                <a:spcPct val="105000"/>
-              </a:lnSpc>
-              <a:spcBef>
-                <a:spcPts val="800"/>
-              </a:spcBef>
-            </a:pPr>
-            <a:r>
-              <a:rPr sz="1600" b="0" i="0">
-                <a:solidFill>
-                  <a:srgbClr val="5A6678"/>
-                </a:solidFill>
-                <a:latin typeface="Calibri"/>
-              </a:rPr>
-              <a:t>0 = no better than random     →     1 = identical maps</a:t>
+              <a:t>IMC: DINO (far left) vs. classical clusterings. Colours are arbitrary; shape match is what counts.</a:t>
             </a:r>
           </a:p>
         </p:txBody>
@@ -6172,117 +6179,21 @@
                 </a:solidFill>
                 <a:latin typeface="Georgia"/>
               </a:rPr>
-              <a:t>What we found</a:t>
-            </a:r>
-          </a:p>
-        </p:txBody>
-      </p:sp>
-      <p:sp>
-        <p:nvSpPr>
-          <p:cNvPr id="4" name="TextBox 3"/>
-          <p:cNvSpPr txBox="1"/>
-          <p:nvPr/>
-        </p:nvSpPr>
-        <p:spPr>
-          <a:xfrm>
-            <a:off x="640080" y="1371600"/>
-            <a:ext cx="5577840" cy="4572000"/>
-          </a:xfrm>
-          <a:prstGeom prst="rect">
-            <a:avLst/>
-          </a:prstGeom>
-          <a:noFill/>
-        </p:spPr>
-        <p:txBody>
-          <a:bodyPr wrap="square" anchor="t" lIns="25400" rIns="25400" tIns="25400" bIns="25400">
-            <a:spAutoFit/>
-          </a:bodyPr>
-          <a:lstStyle/>
-          <a:p>
-            <a:pPr algn="l">
-              <a:lnSpc>
-                <a:spcPct val="105000"/>
-              </a:lnSpc>
-            </a:pPr>
-            <a:r>
-              <a:rPr sz="1600" b="0" i="0">
-                <a:solidFill>
-                  <a:srgbClr val="1A2230"/>
-                </a:solidFill>
-                <a:latin typeface="Calibri"/>
-              </a:rPr>
-              <a:t>• The groups are driven by the overall scattered intensity plus the inner, low-angle (low-q) 2-D diffraction structure.</a:t>
-            </a:r>
-          </a:p>
-          <a:p>
-            <a:pPr algn="l">
-              <a:lnSpc>
-                <a:spcPct val="105000"/>
-              </a:lnSpc>
-              <a:spcBef>
-                <a:spcPts val="800"/>
-              </a:spcBef>
-            </a:pPr>
-            <a:r>
-              <a:rPr sz="1600" b="0" i="0">
-                <a:solidFill>
-                  <a:srgbClr val="1A2230"/>
-                </a:solidFill>
-                <a:latin typeface="Calibri"/>
-              </a:rPr>
-              <a:t>• NOT by crystal orientation (agreement ≈ 0) — the model is rotation-invariant by design.</a:t>
-            </a:r>
-          </a:p>
-          <a:p>
-            <a:pPr algn="l">
-              <a:lnSpc>
-                <a:spcPct val="105000"/>
-              </a:lnSpc>
-              <a:spcBef>
-                <a:spcPts val="800"/>
-              </a:spcBef>
-            </a:pPr>
-            <a:r>
-              <a:rPr sz="1600" b="0" i="0">
-                <a:solidFill>
-                  <a:srgbClr val="1A2230"/>
-                </a:solidFill>
-                <a:latin typeface="Calibri"/>
-              </a:rPr>
-              <a:t>• Uniqueness is material-dependent: IMC maps are distinctive (classical ≈ 0.15); NaPHI is ~half-classical (≈ 0.5).</a:t>
-            </a:r>
-          </a:p>
-          <a:p>
-            <a:pPr algn="l">
-              <a:lnSpc>
-                <a:spcPct val="105000"/>
-              </a:lnSpc>
-              <a:spcBef>
-                <a:spcPts val="800"/>
-              </a:spcBef>
-            </a:pPr>
-            <a:r>
-              <a:rPr sz="1600" b="0" i="0">
-                <a:solidFill>
-                  <a:srgbClr val="1A2230"/>
-                </a:solidFill>
-                <a:latin typeface="Calibri"/>
-              </a:rPr>
-              <a:t>• Log-stretch preprocessing keeps the same basis but sharpens it — more, cleaner groups.</a:t>
-            </a:r>
-          </a:p>
-        </p:txBody>
-      </p:sp>
-      <p:sp>
-        <p:nvSpPr>
-          <p:cNvPr id="5" name="Rounded Rectangle 4"/>
+              <a:t>How to read the two numbers</a:t>
+            </a:r>
+          </a:p>
+        </p:txBody>
+      </p:sp>
+      <p:sp>
+        <p:nvSpPr>
+          <p:cNvPr id="4" name="Rounded Rectangle 3"/>
           <p:cNvSpPr/>
           <p:nvPr/>
         </p:nvSpPr>
         <p:spPr>
           <a:xfrm>
-            <a:off x="6400800" y="1463040"/>
-            <a:ext cx="5212080" cy="4480560"/>
+            <a:off x="822960" y="1737360"/>
+            <a:ext cx="10515600" cy="1920240"/>
           </a:xfrm>
           <a:prstGeom prst="roundRect">
             <a:avLst/>
@@ -6319,30 +6230,89 @@
           </a:p>
         </p:txBody>
       </p:sp>
-      <p:pic>
-        <p:nvPicPr>
-          <p:cNvPr id="6" name="Picture 5" descr="cross_sample.png"/>
-          <p:cNvPicPr>
-            <a:picLocks noChangeAspect="1"/>
-          </p:cNvPicPr>
-          <p:nvPr/>
-        </p:nvPicPr>
-        <p:blipFill>
-          <a:blip r:embed="rId2"/>
-          <a:stretch>
-            <a:fillRect/>
-          </a:stretch>
-        </p:blipFill>
-        <p:spPr>
-          <a:xfrm>
-            <a:off x="6537960" y="2762444"/>
-            <a:ext cx="4937760" cy="1561710"/>
+      <p:sp>
+        <p:nvSpPr>
+          <p:cNvPr id="5" name="Rectangle 4"/>
+          <p:cNvSpPr/>
+          <p:nvPr/>
+        </p:nvSpPr>
+        <p:spPr>
+          <a:xfrm>
+            <a:off x="822960" y="1737360"/>
+            <a:ext cx="201168" cy="1920240"/>
           </a:xfrm>
           <a:prstGeom prst="rect">
             <a:avLst/>
           </a:prstGeom>
-        </p:spPr>
-      </p:pic>
+          <a:solidFill>
+            <a:srgbClr val="065A82"/>
+          </a:solidFill>
+          <a:ln>
+            <a:noFill/>
+          </a:ln>
+          <a:effectLst/>
+        </p:spPr>
+        <p:style>
+          <a:lnRef idx="1">
+            <a:schemeClr val="accent1"/>
+          </a:lnRef>
+          <a:fillRef idx="3">
+            <a:schemeClr val="accent1"/>
+          </a:fillRef>
+          <a:effectRef idx="2">
+            <a:schemeClr val="accent1"/>
+          </a:effectRef>
+          <a:fontRef idx="minor">
+            <a:schemeClr val="lt1"/>
+          </a:fontRef>
+        </p:style>
+        <p:txBody>
+          <a:bodyPr rtlCol="0" anchor="ctr"/>
+          <a:lstStyle/>
+          <a:p>
+            <a:pPr algn="ctr"/>
+          </a:p>
+        </p:txBody>
+      </p:sp>
+      <p:sp>
+        <p:nvSpPr>
+          <p:cNvPr id="6" name="TextBox 5"/>
+          <p:cNvSpPr txBox="1"/>
+          <p:nvPr/>
+        </p:nvSpPr>
+        <p:spPr>
+          <a:xfrm>
+            <a:off x="1188720" y="1737360"/>
+            <a:ext cx="3108960" cy="1920240"/>
+          </a:xfrm>
+          <a:prstGeom prst="rect">
+            <a:avLst/>
+          </a:prstGeom>
+          <a:noFill/>
+        </p:spPr>
+        <p:txBody>
+          <a:bodyPr wrap="square" anchor="ctr" lIns="25400" rIns="25400" tIns="25400" bIns="25400">
+            <a:spAutoFit/>
+          </a:bodyPr>
+          <a:lstStyle/>
+          <a:p>
+            <a:pPr algn="l">
+              <a:lnSpc>
+                <a:spcPct val="105000"/>
+              </a:lnSpc>
+            </a:pPr>
+            <a:r>
+              <a:rPr sz="3400" b="1" i="0">
+                <a:solidFill>
+                  <a:srgbClr val="065A82"/>
+                </a:solidFill>
+                <a:latin typeface="Georgia"/>
+              </a:rPr>
+              <a:t>R²</a:t>
+            </a:r>
+          </a:p>
+        </p:txBody>
+      </p:sp>
       <p:sp>
         <p:nvSpPr>
           <p:cNvPr id="7" name="TextBox 6"/>
@@ -6351,8 +6321,8 @@
         </p:nvSpPr>
         <p:spPr>
           <a:xfrm>
-            <a:off x="6537960" y="4727448"/>
-            <a:ext cx="4937760" cy="301752"/>
+            <a:off x="4480560" y="1737360"/>
+            <a:ext cx="6675120" cy="1920240"/>
           </a:xfrm>
           <a:prstGeom prst="rect">
             <a:avLst/>
@@ -6360,38 +6330,147 @@
           <a:noFill/>
         </p:spPr>
         <p:txBody>
-          <a:bodyPr wrap="square" anchor="t" lIns="25400" rIns="25400" tIns="25400" bIns="25400">
+          <a:bodyPr wrap="square" anchor="ctr" lIns="25400" rIns="25400" tIns="25400" bIns="25400">
             <a:spAutoFit/>
           </a:bodyPr>
           <a:lstStyle/>
           <a:p>
-            <a:pPr algn="ctr">
+            <a:pPr algn="l">
               <a:lnSpc>
                 <a:spcPct val="105000"/>
               </a:lnSpc>
             </a:pPr>
             <a:r>
-              <a:rPr sz="1100" b="0" i="1">
+              <a:rPr sz="1600" b="1" i="0">
+                <a:solidFill>
+                  <a:srgbClr val="1A2230"/>
+                </a:solidFill>
+                <a:latin typeface="Calibri"/>
+              </a:rPr>
+              <a:t>How predictable a property is from the model's fingerprint.</a:t>
+            </a:r>
+          </a:p>
+          <a:p>
+            <a:pPr algn="l">
+              <a:lnSpc>
+                <a:spcPct val="105000"/>
+              </a:lnSpc>
+              <a:spcBef>
+                <a:spcPts val="800"/>
+              </a:spcBef>
+            </a:pPr>
+            <a:r>
+              <a:rPr sz="1600" b="0" i="0">
                 <a:solidFill>
                   <a:srgbClr val="5A6678"/>
                 </a:solidFill>
                 <a:latin typeface="Calibri"/>
               </a:rPr>
-              <a:t>Cross-sample: (a) what's encoded, (b) ablations, (c) classical agreement.</a:t>
-            </a:r>
-          </a:p>
-        </p:txBody>
-      </p:sp>
-      <p:sp>
-        <p:nvSpPr>
-          <p:cNvPr id="8" name="TextBox 7"/>
+              <a:t>0 = the model ignores it     →     1 = fully encoded</a:t>
+            </a:r>
+          </a:p>
+        </p:txBody>
+      </p:sp>
+      <p:sp>
+        <p:nvSpPr>
+          <p:cNvPr id="8" name="Rounded Rectangle 7"/>
+          <p:cNvSpPr/>
+          <p:nvPr/>
+        </p:nvSpPr>
+        <p:spPr>
+          <a:xfrm>
+            <a:off x="822960" y="3977639"/>
+            <a:ext cx="10515600" cy="1920240"/>
+          </a:xfrm>
+          <a:prstGeom prst="roundRect">
+            <a:avLst/>
+          </a:prstGeom>
+          <a:solidFill>
+            <a:srgbClr val="FFFFFF"/>
+          </a:solidFill>
+          <a:ln w="12700">
+            <a:solidFill>
+              <a:srgbClr val="CADCFC"/>
+            </a:solidFill>
+          </a:ln>
+          <a:effectLst/>
+        </p:spPr>
+        <p:style>
+          <a:lnRef idx="1">
+            <a:schemeClr val="accent1"/>
+          </a:lnRef>
+          <a:fillRef idx="3">
+            <a:schemeClr val="accent1"/>
+          </a:fillRef>
+          <a:effectRef idx="2">
+            <a:schemeClr val="accent1"/>
+          </a:effectRef>
+          <a:fontRef idx="minor">
+            <a:schemeClr val="lt1"/>
+          </a:fontRef>
+        </p:style>
+        <p:txBody>
+          <a:bodyPr rtlCol="0" anchor="ctr"/>
+          <a:lstStyle/>
+          <a:p>
+            <a:pPr algn="ctr"/>
+          </a:p>
+        </p:txBody>
+      </p:sp>
+      <p:sp>
+        <p:nvSpPr>
+          <p:cNvPr id="9" name="Rectangle 8"/>
+          <p:cNvSpPr/>
+          <p:nvPr/>
+        </p:nvSpPr>
+        <p:spPr>
+          <a:xfrm>
+            <a:off x="822960" y="3977639"/>
+            <a:ext cx="201168" cy="1920240"/>
+          </a:xfrm>
+          <a:prstGeom prst="rect">
+            <a:avLst/>
+          </a:prstGeom>
+          <a:solidFill>
+            <a:srgbClr val="1C7293"/>
+          </a:solidFill>
+          <a:ln>
+            <a:noFill/>
+          </a:ln>
+          <a:effectLst/>
+        </p:spPr>
+        <p:style>
+          <a:lnRef idx="1">
+            <a:schemeClr val="accent1"/>
+          </a:lnRef>
+          <a:fillRef idx="3">
+            <a:schemeClr val="accent1"/>
+          </a:fillRef>
+          <a:effectRef idx="2">
+            <a:schemeClr val="accent1"/>
+          </a:effectRef>
+          <a:fontRef idx="minor">
+            <a:schemeClr val="lt1"/>
+          </a:fontRef>
+        </p:style>
+        <p:txBody>
+          <a:bodyPr rtlCol="0" anchor="ctr"/>
+          <a:lstStyle/>
+          <a:p>
+            <a:pPr algn="ctr"/>
+          </a:p>
+        </p:txBody>
+      </p:sp>
+      <p:sp>
+        <p:nvSpPr>
+          <p:cNvPr id="10" name="TextBox 9"/>
           <p:cNvSpPr txBox="1"/>
           <p:nvPr/>
         </p:nvSpPr>
         <p:spPr>
           <a:xfrm>
-            <a:off x="6537960" y="1600200"/>
-            <a:ext cx="4937760" cy="457200"/>
+            <a:off x="1188720" y="3977639"/>
+            <a:ext cx="3108960" cy="1920240"/>
           </a:xfrm>
           <a:prstGeom prst="rect">
             <a:avLst/>
@@ -6399,24 +6478,82 @@
           <a:noFill/>
         </p:spPr>
         <p:txBody>
-          <a:bodyPr wrap="square" anchor="t" lIns="25400" rIns="25400" tIns="25400" bIns="25400">
+          <a:bodyPr wrap="square" anchor="ctr" lIns="25400" rIns="25400" tIns="25400" bIns="25400">
             <a:spAutoFit/>
           </a:bodyPr>
           <a:lstStyle/>
           <a:p>
-            <a:pPr algn="ctr">
+            <a:pPr algn="l">
               <a:lnSpc>
                 <a:spcPct val="105000"/>
               </a:lnSpc>
             </a:pPr>
             <a:r>
-              <a:rPr sz="1400" b="0" i="1">
+              <a:rPr sz="3400" b="1" i="0">
+                <a:solidFill>
+                  <a:srgbClr val="1C7293"/>
+                </a:solidFill>
+                <a:latin typeface="Georgia"/>
+              </a:rPr>
+              <a:t>ARI / AMI</a:t>
+            </a:r>
+          </a:p>
+        </p:txBody>
+      </p:sp>
+      <p:sp>
+        <p:nvSpPr>
+          <p:cNvPr id="11" name="TextBox 10"/>
+          <p:cNvSpPr txBox="1"/>
+          <p:nvPr/>
+        </p:nvSpPr>
+        <p:spPr>
+          <a:xfrm>
+            <a:off x="4480560" y="3977639"/>
+            <a:ext cx="6675120" cy="1920240"/>
+          </a:xfrm>
+          <a:prstGeom prst="rect">
+            <a:avLst/>
+          </a:prstGeom>
+          <a:noFill/>
+        </p:spPr>
+        <p:txBody>
+          <a:bodyPr wrap="square" anchor="ctr" lIns="25400" rIns="25400" tIns="25400" bIns="25400">
+            <a:spAutoFit/>
+          </a:bodyPr>
+          <a:lstStyle/>
+          <a:p>
+            <a:pPr algn="l">
+              <a:lnSpc>
+                <a:spcPct val="105000"/>
+              </a:lnSpc>
+            </a:pPr>
+            <a:r>
+              <a:rPr sz="1600" b="1" i="0">
+                <a:solidFill>
+                  <a:srgbClr val="1A2230"/>
+                </a:solidFill>
+                <a:latin typeface="Calibri"/>
+              </a:rPr>
+              <a:t>How much two maps agree, correcting for chance.</a:t>
+            </a:r>
+          </a:p>
+          <a:p>
+            <a:pPr algn="l">
+              <a:lnSpc>
+                <a:spcPct val="105000"/>
+              </a:lnSpc>
+              <a:spcBef>
+                <a:spcPts val="800"/>
+              </a:spcBef>
+            </a:pPr>
+            <a:r>
+              <a:rPr sz="1600" b="0" i="0">
                 <a:solidFill>
                   <a:srgbClr val="5A6678"/>
                 </a:solidFill>
                 <a:latin typeface="Calibri"/>
               </a:rPr>
-              <a:t>Across IMC SI3/SI4/SI5 and NaPHI</a:t>
+              <a:t>0 = no better than random     →     1 = identical maps</a:t>
             </a:r>
           </a:p>
         </p:txBody>
@@ -6454,6 +6591,254 @@
             <a:avLst/>
           </a:prstGeom>
           <a:solidFill>
+            <a:srgbClr val="F4F7FA"/>
+          </a:solidFill>
+          <a:ln>
+            <a:noFill/>
+          </a:ln>
+          <a:effectLst/>
+        </p:spPr>
+        <p:style>
+          <a:lnRef idx="1">
+            <a:schemeClr val="accent1"/>
+          </a:lnRef>
+          <a:fillRef idx="3">
+            <a:schemeClr val="accent1"/>
+          </a:fillRef>
+          <a:effectRef idx="2">
+            <a:schemeClr val="accent1"/>
+          </a:effectRef>
+          <a:fontRef idx="minor">
+            <a:schemeClr val="lt1"/>
+          </a:fontRef>
+        </p:style>
+        <p:txBody>
+          <a:bodyPr rtlCol="0" anchor="ctr"/>
+          <a:lstStyle/>
+          <a:p>
+            <a:pPr algn="ctr"/>
+          </a:p>
+        </p:txBody>
+      </p:sp>
+      <p:sp>
+        <p:nvSpPr>
+          <p:cNvPr id="3" name="TextBox 2"/>
+          <p:cNvSpPr txBox="1"/>
+          <p:nvPr/>
+        </p:nvSpPr>
+        <p:spPr>
+          <a:xfrm>
+            <a:off x="640080" y="365760"/>
+            <a:ext cx="10972800" cy="640080"/>
+          </a:xfrm>
+          <a:prstGeom prst="rect">
+            <a:avLst/>
+          </a:prstGeom>
+          <a:noFill/>
+        </p:spPr>
+        <p:txBody>
+          <a:bodyPr wrap="square" anchor="t" lIns="25400" rIns="25400" tIns="25400" bIns="25400">
+            <a:spAutoFit/>
+          </a:bodyPr>
+          <a:lstStyle/>
+          <a:p>
+            <a:pPr algn="l">
+              <a:lnSpc>
+                <a:spcPct val="105000"/>
+              </a:lnSpc>
+            </a:pPr>
+            <a:r>
+              <a:rPr sz="3200" b="1" i="0">
+                <a:solidFill>
+                  <a:srgbClr val="065A82"/>
+                </a:solidFill>
+                <a:latin typeface="Georgia"/>
+              </a:rPr>
+              <a:t>Across all samples</a:t>
+            </a:r>
+          </a:p>
+        </p:txBody>
+      </p:sp>
+      <p:pic>
+        <p:nvPicPr>
+          <p:cNvPr id="4" name="Picture 3" descr="cross_all.png"/>
+          <p:cNvPicPr>
+            <a:picLocks noChangeAspect="1"/>
+          </p:cNvPicPr>
+          <p:nvPr/>
+        </p:nvPicPr>
+        <p:blipFill>
+          <a:blip r:embed="rId2"/>
+          <a:stretch>
+            <a:fillRect/>
+          </a:stretch>
+        </p:blipFill>
+        <p:spPr>
+          <a:xfrm>
+            <a:off x="1064154" y="1051560"/>
+            <a:ext cx="10124651" cy="2880360"/>
+          </a:xfrm>
+          <a:prstGeom prst="rect">
+            <a:avLst/>
+          </a:prstGeom>
+        </p:spPr>
+      </p:pic>
+      <p:sp>
+        <p:nvSpPr>
+          <p:cNvPr id="5" name="TextBox 4"/>
+          <p:cNvSpPr txBox="1"/>
+          <p:nvPr/>
+        </p:nvSpPr>
+        <p:spPr>
+          <a:xfrm>
+            <a:off x="457200" y="3950207"/>
+            <a:ext cx="11338560" cy="301752"/>
+          </a:xfrm>
+          <a:prstGeom prst="rect">
+            <a:avLst/>
+          </a:prstGeom>
+          <a:noFill/>
+        </p:spPr>
+        <p:txBody>
+          <a:bodyPr wrap="square" anchor="t" lIns="25400" rIns="25400" tIns="25400" bIns="25400">
+            <a:spAutoFit/>
+          </a:bodyPr>
+          <a:lstStyle/>
+          <a:p>
+            <a:pPr algn="ctr">
+              <a:lnSpc>
+                <a:spcPct val="105000"/>
+              </a:lnSpc>
+            </a:pPr>
+            <a:r>
+              <a:rPr sz="1100" b="0" i="1">
+                <a:solidFill>
+                  <a:srgbClr val="5A6678"/>
+                </a:solidFill>
+                <a:latin typeface="Calibri"/>
+              </a:rPr>
+              <a:t>IMC SI3/SI4 · NaPHI (Na007b) · EuInAs. (a) classical agreement; (b) intensity dependence; (c) low-q vs high-q.</a:t>
+            </a:r>
+          </a:p>
+        </p:txBody>
+      </p:sp>
+      <p:sp>
+        <p:nvSpPr>
+          <p:cNvPr id="6" name="Rounded Rectangle 5"/>
+          <p:cNvSpPr/>
+          <p:nvPr/>
+        </p:nvSpPr>
+        <p:spPr>
+          <a:xfrm>
+            <a:off x="640080" y="4617720"/>
+            <a:ext cx="5394960" cy="1783080"/>
+          </a:xfrm>
+          <a:prstGeom prst="roundRect">
+            <a:avLst/>
+          </a:prstGeom>
+          <a:solidFill>
+            <a:srgbClr val="CADCFC"/>
+          </a:solidFill>
+          <a:ln>
+            <a:noFill/>
+          </a:ln>
+          <a:effectLst/>
+        </p:spPr>
+        <p:style>
+          <a:lnRef idx="1">
+            <a:schemeClr val="accent1"/>
+          </a:lnRef>
+          <a:fillRef idx="3">
+            <a:schemeClr val="accent1"/>
+          </a:fillRef>
+          <a:effectRef idx="2">
+            <a:schemeClr val="accent1"/>
+          </a:effectRef>
+          <a:fontRef idx="minor">
+            <a:schemeClr val="lt1"/>
+          </a:fontRef>
+        </p:style>
+        <p:txBody>
+          <a:bodyPr rtlCol="0" anchor="ctr"/>
+          <a:lstStyle/>
+          <a:p>
+            <a:pPr algn="ctr"/>
+          </a:p>
+        </p:txBody>
+      </p:sp>
+      <p:sp>
+        <p:nvSpPr>
+          <p:cNvPr id="7" name="TextBox 6"/>
+          <p:cNvSpPr txBox="1"/>
+          <p:nvPr/>
+        </p:nvSpPr>
+        <p:spPr>
+          <a:xfrm>
+            <a:off x="868680" y="4736592"/>
+            <a:ext cx="4983480" cy="1554480"/>
+          </a:xfrm>
+          <a:prstGeom prst="rect">
+            <a:avLst/>
+          </a:prstGeom>
+          <a:noFill/>
+        </p:spPr>
+        <p:txBody>
+          <a:bodyPr wrap="square" anchor="ctr" lIns="25400" rIns="25400" tIns="25400" bIns="25400">
+            <a:spAutoFit/>
+          </a:bodyPr>
+          <a:lstStyle/>
+          <a:p>
+            <a:pPr algn="l">
+              <a:lnSpc>
+                <a:spcPct val="105000"/>
+              </a:lnSpc>
+            </a:pPr>
+            <a:r>
+              <a:rPr sz="1500" b="1" i="0">
+                <a:solidFill>
+                  <a:srgbClr val="21295C"/>
+                </a:solidFill>
+                <a:latin typeface="Calibri"/>
+              </a:rPr>
+              <a:t>Same physical basis everywhere</a:t>
+            </a:r>
+          </a:p>
+          <a:p>
+            <a:pPr algn="l">
+              <a:lnSpc>
+                <a:spcPct val="105000"/>
+              </a:lnSpc>
+              <a:spcBef>
+                <a:spcPts val="600"/>
+              </a:spcBef>
+            </a:pPr>
+            <a:r>
+              <a:rPr sz="1400" b="0" i="0">
+                <a:solidFill>
+                  <a:srgbClr val="1A2230"/>
+                </a:solidFill>
+                <a:latin typeface="Calibri"/>
+              </a:rPr>
+              <a:t>Scattered intensity + low-q 2-D structure drive every sample; removing intensity or the low-q band breaks the map.</a:t>
+            </a:r>
+          </a:p>
+        </p:txBody>
+      </p:sp>
+      <p:sp>
+        <p:nvSpPr>
+          <p:cNvPr id="8" name="Rounded Rectangle 7"/>
+          <p:cNvSpPr/>
+          <p:nvPr/>
+        </p:nvSpPr>
+        <p:spPr>
+          <a:xfrm>
+            <a:off x="6217920" y="4617720"/>
+            <a:ext cx="5394960" cy="1783080"/>
+          </a:xfrm>
+          <a:prstGeom prst="roundRect">
+            <a:avLst/>
+          </a:prstGeom>
+          <a:solidFill>
             <a:srgbClr val="21295C"/>
           </a:solidFill>
           <a:ln>
@@ -6485,66 +6870,22 @@
       </p:sp>
       <p:sp>
         <p:nvSpPr>
-          <p:cNvPr id="3" name="Rectangle 2"/>
-          <p:cNvSpPr/>
-          <p:nvPr/>
-        </p:nvSpPr>
-        <p:spPr>
-          <a:xfrm>
-            <a:off x="0" y="0"/>
-            <a:ext cx="292608" cy="6858000"/>
+          <p:cNvPr id="9" name="TextBox 8"/>
+          <p:cNvSpPr txBox="1"/>
+          <p:nvPr/>
+        </p:nvSpPr>
+        <p:spPr>
+          <a:xfrm>
+            <a:off x="6446520" y="4736592"/>
+            <a:ext cx="4983480" cy="1554480"/>
           </a:xfrm>
           <a:prstGeom prst="rect">
             <a:avLst/>
           </a:prstGeom>
-          <a:solidFill>
-            <a:srgbClr val="E8A33D"/>
-          </a:solidFill>
-          <a:ln>
-            <a:noFill/>
-          </a:ln>
-          <a:effectLst/>
-        </p:spPr>
-        <p:style>
-          <a:lnRef idx="1">
-            <a:schemeClr val="accent1"/>
-          </a:lnRef>
-          <a:fillRef idx="3">
-            <a:schemeClr val="accent1"/>
-          </a:fillRef>
-          <a:effectRef idx="2">
-            <a:schemeClr val="accent1"/>
-          </a:effectRef>
-          <a:fontRef idx="minor">
-            <a:schemeClr val="lt1"/>
-          </a:fontRef>
-        </p:style>
-        <p:txBody>
-          <a:bodyPr rtlCol="0" anchor="ctr"/>
-          <a:lstStyle/>
-          <a:p>
-            <a:pPr algn="ctr"/>
-          </a:p>
-        </p:txBody>
-      </p:sp>
-      <p:sp>
-        <p:nvSpPr>
-          <p:cNvPr id="4" name="TextBox 3"/>
-          <p:cNvSpPr txBox="1"/>
-          <p:nvPr/>
-        </p:nvSpPr>
-        <p:spPr>
-          <a:xfrm>
-            <a:off x="914400" y="548640"/>
-            <a:ext cx="10058400" cy="822960"/>
-          </a:xfrm>
-          <a:prstGeom prst="rect">
-            <a:avLst/>
-          </a:prstGeom>
           <a:noFill/>
         </p:spPr>
         <p:txBody>
-          <a:bodyPr wrap="square" anchor="t" lIns="25400" rIns="25400" tIns="25400" bIns="25400">
+          <a:bodyPr wrap="square" anchor="ctr" lIns="25400" rIns="25400" tIns="25400" bIns="25400">
             <a:spAutoFit/>
           </a:bodyPr>
           <a:lstStyle/>
@@ -6555,90 +6896,51 @@
               </a:lnSpc>
             </a:pPr>
             <a:r>
-              <a:rPr sz="3400" b="1" i="0">
+              <a:rPr sz="1500" b="1" i="0">
+                <a:solidFill>
+                  <a:srgbClr val="E8A33D"/>
+                </a:solidFill>
+                <a:latin typeface="Calibri"/>
+              </a:rPr>
+              <a:t>Distinctiveness varies by material</a:t>
+            </a:r>
+          </a:p>
+          <a:p>
+            <a:pPr algn="l">
+              <a:lnSpc>
+                <a:spcPct val="105000"/>
+              </a:lnSpc>
+              <a:spcBef>
+                <a:spcPts val="600"/>
+              </a:spcBef>
+            </a:pPr>
+            <a:r>
+              <a:rPr sz="1400" b="0" i="0">
                 <a:solidFill>
                   <a:srgbClr val="FFFFFF"/>
                 </a:solidFill>
-                <a:latin typeface="Georgia"/>
-              </a:rPr>
-              <a:t>What it means</a:t>
-            </a:r>
-          </a:p>
-        </p:txBody>
-      </p:sp>
-      <p:sp>
-        <p:nvSpPr>
-          <p:cNvPr id="5" name="TextBox 4"/>
-          <p:cNvSpPr txBox="1"/>
-          <p:nvPr/>
-        </p:nvSpPr>
-        <p:spPr>
-          <a:xfrm>
-            <a:off x="914400" y="1737360"/>
-            <a:ext cx="10424160" cy="4389120"/>
-          </a:xfrm>
-          <a:prstGeom prst="rect">
-            <a:avLst/>
-          </a:prstGeom>
-          <a:noFill/>
-        </p:spPr>
-        <p:txBody>
-          <a:bodyPr wrap="square" anchor="t" lIns="25400" rIns="25400" tIns="25400" bIns="25400">
-            <a:spAutoFit/>
-          </a:bodyPr>
-          <a:lstStyle/>
+                <a:latin typeface="Calibri"/>
+              </a:rPr>
+              <a:t>IMC: classical ARI ≈ 0.1–0.2 (distinctive). NaPHI &amp; EuInAs: ≈ 0.5 (classical gets most of the way).</a:t>
+            </a:r>
+          </a:p>
           <a:p>
             <a:pPr algn="l">
               <a:lnSpc>
-                <a:spcPct val="110000"/>
-              </a:lnSpc>
-            </a:pPr>
-            <a:r>
-              <a:rPr sz="1900" b="0" i="0">
-                <a:solidFill>
-                  <a:srgbClr val="FFFFFF"/>
+                <a:spcPct val="105000"/>
+              </a:lnSpc>
+              <a:spcBef>
+                <a:spcPts val="500"/>
+              </a:spcBef>
+            </a:pPr>
+            <a:r>
+              <a:rPr sz="1300" b="0" i="0">
+                <a:solidFill>
+                  <a:srgbClr val="CADCFC"/>
                 </a:solidFill>
                 <a:latin typeface="Calibri"/>
               </a:rPr>
-              <a:t>The model groups regions by how much, and what, they diffract at low angles — crystallinity, molecular packing, and thickness. A physically sensible axis, not an arbitrary black box.</a:t>
-            </a:r>
-          </a:p>
-          <a:p>
-            <a:pPr algn="l">
-              <a:lnSpc>
-                <a:spcPct val="110000"/>
-              </a:lnSpc>
-              <a:spcBef>
-                <a:spcPts val="1600"/>
-              </a:spcBef>
-            </a:pPr>
-            <a:r>
-              <a:rPr sz="1700" b="0" i="0">
-                <a:solidFill>
-                  <a:srgbClr val="CADCFC"/>
-                </a:solidFill>
-                <a:latin typeface="Calibri"/>
-              </a:rPr>
-              <a:t>For IMC it is genuinely distinctive (a standard virtual-detector / PCA map does not reproduce it); for NaPHI it stays closer to classical.</a:t>
-            </a:r>
-          </a:p>
-          <a:p>
-            <a:pPr algn="l">
-              <a:lnSpc>
-                <a:spcPct val="110000"/>
-              </a:lnSpc>
-              <a:spcBef>
-                <a:spcPts val="1600"/>
-              </a:spcBef>
-            </a:pPr>
-            <a:r>
-              <a:rPr sz="1500" b="0" i="1">
-                <a:solidFill>
-                  <a:srgbClr val="CADCFC"/>
-                </a:solidFill>
-                <a:latin typeface="Calibri"/>
-              </a:rPr>
-              <a:t>Caveat: “scattered intensity” blends crystallinity with sample thickness — a thickness map would separate the two.</a:t>
+              <a:t>EuInAs alone also tracks crystal orientation (zone-axis AMI ≈ 0.3).</a:t>
             </a:r>
           </a:p>
         </p:txBody>

</xml_diff>

<commit_message>
interpret: include IMC_SI5 in classical comparison + all-samples explainer
Added classical-baseline test + comparable report_auto.md for IMC_SI5
(classical best ARI 0.21 -> distinctive, like the other IMC films), reusing
its offline probe/ablation/orientation numbers and WITHOUT overwriting its
curated manuscript figures. cross_all figure + explainer PPTX/PDF now cover
all 6 runs (IMC SI3/SI4/SI5, NaPHI, EuInAs); build_cross_all.py made
re-runnable. Superfolder refreshed.

Co-Authored-By: Claude Opus 4.8 (1M context) <noreply@anthropic.com>
</commit_message>
<xml_diff>
--- a/docs/explainer/interpretation_explainer.pptx
+++ b/docs/explainer/interpretation_explainer.pptx
@@ -6675,8 +6675,8 @@
         </p:blipFill>
         <p:spPr>
           <a:xfrm>
-            <a:off x="1064154" y="1051560"/>
-            <a:ext cx="10124651" cy="2880360"/>
+            <a:off x="671565" y="1051560"/>
+            <a:ext cx="10909828" cy="2880360"/>
           </a:xfrm>
           <a:prstGeom prst="rect">
             <a:avLst/>
@@ -6717,7 +6717,7 @@
                 </a:solidFill>
                 <a:latin typeface="Calibri"/>
               </a:rPr>
-              <a:t>IMC SI3/SI4 · NaPHI (Na007b) · EuInAs. (a) classical agreement; (b) intensity dependence; (c) low-q vs high-q.</a:t>
+              <a:t>IMC SI3/SI4/SI5 · NaPHI (Na007b) · EuInAs. (a) classical agreement; (b) intensity dependence; (c) low-q vs high-q.</a:t>
             </a:r>
           </a:p>
         </p:txBody>

</xml_diff>